<commit_message>
Fix pitch slide 3 layout
</commit_message>
<xml_diff>
--- a/pitch/ratzon_pitch.pptx
+++ b/pitch/ratzon_pitch.pptx
@@ -5333,75 +5333,63 @@
       </p:sp>
       <p:sp>
         <p:nvSpPr>
-          <p:cNvPr id="50" name="Text 48"/>
-          <p:cNvSpPr/>
-          <p:nvPr/>
-        </p:nvSpPr>
-        <p:spPr>
-          <a:xfrm>
-            <a:off x="5559552" y="4160520"/>
-            <a:ext cx="914400" cy="118872"/>
-          </a:xfrm>
-          <a:prstGeom prst="rect">
-            <a:avLst/>
-          </a:prstGeom>
-          <a:noFill/>
-          <a:ln/>
-        </p:spPr>
-        <p:txBody>
-          <a:bodyPr wrap="square" lIns="0" tIns="0" rIns="0" bIns="0" rtlCol="0" anchor="ctr"/>
-          <a:lstStyle/>
-          <a:p>
-            <a:pPr indent="0" marL="0">
-              <a:buNone/>
-            </a:pPr>
-            <a:r>
-              <a:rPr lang="en-US" sz="850" b="1" dirty="0">
-                <a:solidFill>
-                  <a:srgbClr val="F7F2EE"/>
-                </a:solidFill>
-              </a:rPr>
-              <a:t>Quote</a:t>
-            </a:r>
-            <a:endParaRPr lang="en-US" sz="850" dirty="0"/>
-          </a:p>
-        </p:txBody>
-      </p:sp>
-      <p:sp>
-        <p:nvSpPr>
-          <p:cNvPr id="51" name="Text 49"/>
-          <p:cNvSpPr/>
-          <p:nvPr/>
-        </p:nvSpPr>
-        <p:spPr>
-          <a:xfrm>
-            <a:off x="5559552" y="4352544"/>
-            <a:ext cx="914400" cy="128016"/>
-          </a:xfrm>
-          <a:prstGeom prst="rect">
-            <a:avLst/>
-          </a:prstGeom>
-          <a:noFill/>
-          <a:ln/>
-        </p:spPr>
-        <p:txBody>
-          <a:bodyPr wrap="square" lIns="0" tIns="0" rIns="0" bIns="0" rtlCol="0" anchor="ctr"/>
-          <a:lstStyle/>
-          <a:p>
-            <a:pPr indent="0" marL="0">
-              <a:buNone/>
-            </a:pPr>
-            <a:r>
-              <a:rPr lang="en-US" sz="750" b="1" dirty="0">
-                <a:solidFill>
-                  <a:srgbClr val="B8B0AA"/>
-                </a:solidFill>
-              </a:rPr>
-              <a:t>Real-time route</a:t>
-            </a:r>
-            <a:endParaRPr lang="en-US" sz="750" dirty="0"/>
-          </a:p>
-        </p:txBody>
+          <p:cNvPr id="50" name="Shape 48"/>
+          <p:cNvSpPr/>
+          <p:nvPr/>
+        </p:nvSpPr>
+        <p:spPr>
+          <a:xfrm>
+            <a:off x="5870448" y="4187952"/>
+            <a:ext cx="292608" cy="292608"/>
+          </a:xfrm>
+          <a:prstGeom prst="ellipse">
+            <a:avLst/>
+          </a:prstGeom>
+          <a:solidFill>
+            <a:srgbClr val="D6382E">
+              <a:alpha val="92000"/>
+            </a:srgbClr>
+          </a:solidFill>
+          <a:ln w="10160">
+            <a:solidFill>
+              <a:srgbClr val="FFFFFF">
+                <a:alpha val="20000"/>
+              </a:srgbClr>
+            </a:solidFill>
+            <a:prstDash val="solid"/>
+          </a:ln>
+        </p:spPr>
+      </p:sp>
+      <p:sp>
+        <p:nvSpPr>
+          <p:cNvPr id="51" name="Shape 49"/>
+          <p:cNvSpPr/>
+          <p:nvPr/>
+        </p:nvSpPr>
+        <p:spPr>
+          <a:xfrm>
+            <a:off x="5806440" y="4517136"/>
+            <a:ext cx="420624" cy="36576"/>
+          </a:xfrm>
+          <a:prstGeom prst="roundRect">
+            <a:avLst>
+              <a:gd name="adj" fmla="val 50000"/>
+            </a:avLst>
+          </a:prstGeom>
+          <a:solidFill>
+            <a:srgbClr val="FFFFFF">
+              <a:alpha val="22000"/>
+            </a:srgbClr>
+          </a:solidFill>
+          <a:ln w="12700">
+            <a:solidFill>
+              <a:srgbClr val="FFFFFF">
+                <a:alpha val="0"/>
+              </a:srgbClr>
+            </a:solidFill>
+            <a:prstDash val="solid"/>
+          </a:ln>
+        </p:spPr>
       </p:sp>
       <p:sp>
         <p:nvSpPr>
@@ -5430,75 +5418,63 @@
       </p:sp>
       <p:sp>
         <p:nvSpPr>
-          <p:cNvPr id="53" name="Text 51"/>
-          <p:cNvSpPr/>
-          <p:nvPr/>
-        </p:nvSpPr>
-        <p:spPr>
-          <a:xfrm>
-            <a:off x="6793992" y="4160520"/>
-            <a:ext cx="914400" cy="118872"/>
-          </a:xfrm>
-          <a:prstGeom prst="rect">
-            <a:avLst/>
-          </a:prstGeom>
-          <a:noFill/>
-          <a:ln/>
-        </p:spPr>
-        <p:txBody>
-          <a:bodyPr wrap="square" lIns="0" tIns="0" rIns="0" bIns="0" rtlCol="0" anchor="ctr"/>
-          <a:lstStyle/>
-          <a:p>
-            <a:pPr indent="0" marL="0">
-              <a:buNone/>
-            </a:pPr>
-            <a:r>
-              <a:rPr lang="en-US" sz="850" b="1" dirty="0">
-                <a:solidFill>
-                  <a:srgbClr val="F7F2EE"/>
-                </a:solidFill>
-              </a:rPr>
-              <a:t>Risk</a:t>
-            </a:r>
-            <a:endParaRPr lang="en-US" sz="850" dirty="0"/>
-          </a:p>
-        </p:txBody>
-      </p:sp>
-      <p:sp>
-        <p:nvSpPr>
-          <p:cNvPr id="54" name="Text 52"/>
-          <p:cNvSpPr/>
-          <p:nvPr/>
-        </p:nvSpPr>
-        <p:spPr>
-          <a:xfrm>
-            <a:off x="6793992" y="4352544"/>
-            <a:ext cx="914400" cy="128016"/>
-          </a:xfrm>
-          <a:prstGeom prst="rect">
-            <a:avLst/>
-          </a:prstGeom>
-          <a:noFill/>
-          <a:ln/>
-        </p:spPr>
-        <p:txBody>
-          <a:bodyPr wrap="square" lIns="0" tIns="0" rIns="0" bIns="0" rtlCol="0" anchor="ctr"/>
-          <a:lstStyle/>
-          <a:p>
-            <a:pPr indent="0" marL="0">
-              <a:buNone/>
-            </a:pPr>
-            <a:r>
-              <a:rPr lang="en-US" sz="750" b="1" dirty="0">
-                <a:solidFill>
-                  <a:srgbClr val="B8B0AA"/>
-                </a:solidFill>
-              </a:rPr>
-              <a:t>Low slippage</a:t>
-            </a:r>
-            <a:endParaRPr lang="en-US" sz="750" dirty="0"/>
-          </a:p>
-        </p:txBody>
+          <p:cNvPr id="53" name="Shape 51"/>
+          <p:cNvSpPr/>
+          <p:nvPr/>
+        </p:nvSpPr>
+        <p:spPr>
+          <a:xfrm>
+            <a:off x="7104888" y="4187952"/>
+            <a:ext cx="292608" cy="292608"/>
+          </a:xfrm>
+          <a:prstGeom prst="ellipse">
+            <a:avLst/>
+          </a:prstGeom>
+          <a:solidFill>
+            <a:srgbClr val="49D17A">
+              <a:alpha val="92000"/>
+            </a:srgbClr>
+          </a:solidFill>
+          <a:ln w="10160">
+            <a:solidFill>
+              <a:srgbClr val="FFFFFF">
+                <a:alpha val="20000"/>
+              </a:srgbClr>
+            </a:solidFill>
+            <a:prstDash val="solid"/>
+          </a:ln>
+        </p:spPr>
+      </p:sp>
+      <p:sp>
+        <p:nvSpPr>
+          <p:cNvPr id="54" name="Shape 52"/>
+          <p:cNvSpPr/>
+          <p:nvPr/>
+        </p:nvSpPr>
+        <p:spPr>
+          <a:xfrm>
+            <a:off x="7040880" y="4517136"/>
+            <a:ext cx="420624" cy="36576"/>
+          </a:xfrm>
+          <a:prstGeom prst="roundRect">
+            <a:avLst>
+              <a:gd name="adj" fmla="val 50000"/>
+            </a:avLst>
+          </a:prstGeom>
+          <a:solidFill>
+            <a:srgbClr val="FFFFFF">
+              <a:alpha val="22000"/>
+            </a:srgbClr>
+          </a:solidFill>
+          <a:ln w="12700">
+            <a:solidFill>
+              <a:srgbClr val="FFFFFF">
+                <a:alpha val="0"/>
+              </a:srgbClr>
+            </a:solidFill>
+            <a:prstDash val="solid"/>
+          </a:ln>
+        </p:spPr>
       </p:sp>
       <p:sp>
         <p:nvSpPr>
@@ -5527,75 +5503,63 @@
       </p:sp>
       <p:sp>
         <p:nvSpPr>
-          <p:cNvPr id="56" name="Text 54"/>
-          <p:cNvSpPr/>
-          <p:nvPr/>
-        </p:nvSpPr>
-        <p:spPr>
-          <a:xfrm>
-            <a:off x="8028432" y="4160520"/>
-            <a:ext cx="914400" cy="118872"/>
-          </a:xfrm>
-          <a:prstGeom prst="rect">
-            <a:avLst/>
-          </a:prstGeom>
-          <a:noFill/>
-          <a:ln/>
-        </p:spPr>
-        <p:txBody>
-          <a:bodyPr wrap="square" lIns="0" tIns="0" rIns="0" bIns="0" rtlCol="0" anchor="ctr"/>
-          <a:lstStyle/>
-          <a:p>
-            <a:pPr indent="0" marL="0">
-              <a:buNone/>
-            </a:pPr>
-            <a:r>
-              <a:rPr lang="en-US" sz="850" b="1" dirty="0">
-                <a:solidFill>
-                  <a:srgbClr val="F7F2EE"/>
-                </a:solidFill>
-              </a:rPr>
-              <a:t>Fees</a:t>
-            </a:r>
-            <a:endParaRPr lang="en-US" sz="850" dirty="0"/>
-          </a:p>
-        </p:txBody>
-      </p:sp>
-      <p:sp>
-        <p:nvSpPr>
-          <p:cNvPr id="57" name="Text 55"/>
-          <p:cNvSpPr/>
-          <p:nvPr/>
-        </p:nvSpPr>
-        <p:spPr>
-          <a:xfrm>
-            <a:off x="8028432" y="4352544"/>
-            <a:ext cx="914400" cy="128016"/>
-          </a:xfrm>
-          <a:prstGeom prst="rect">
-            <a:avLst/>
-          </a:prstGeom>
-          <a:noFill/>
-          <a:ln/>
-        </p:spPr>
-        <p:txBody>
-          <a:bodyPr wrap="square" lIns="0" tIns="0" rIns="0" bIns="0" rtlCol="0" anchor="ctr"/>
-          <a:lstStyle/>
-          <a:p>
-            <a:pPr indent="0" marL="0">
-              <a:buNone/>
-            </a:pPr>
-            <a:r>
-              <a:rPr lang="en-US" sz="750" b="1" dirty="0">
-                <a:solidFill>
-                  <a:srgbClr val="B8B0AA"/>
-                </a:solidFill>
-              </a:rPr>
-              <a:t>Solana cost</a:t>
-            </a:r>
-            <a:endParaRPr lang="en-US" sz="750" dirty="0"/>
-          </a:p>
-        </p:txBody>
+          <p:cNvPr id="56" name="Shape 54"/>
+          <p:cNvSpPr/>
+          <p:nvPr/>
+        </p:nvSpPr>
+        <p:spPr>
+          <a:xfrm>
+            <a:off x="8339328" y="4187952"/>
+            <a:ext cx="292608" cy="292608"/>
+          </a:xfrm>
+          <a:prstGeom prst="ellipse">
+            <a:avLst/>
+          </a:prstGeom>
+          <a:solidFill>
+            <a:srgbClr val="55D8D1">
+              <a:alpha val="92000"/>
+            </a:srgbClr>
+          </a:solidFill>
+          <a:ln w="10160">
+            <a:solidFill>
+              <a:srgbClr val="FFFFFF">
+                <a:alpha val="20000"/>
+              </a:srgbClr>
+            </a:solidFill>
+            <a:prstDash val="solid"/>
+          </a:ln>
+        </p:spPr>
+      </p:sp>
+      <p:sp>
+        <p:nvSpPr>
+          <p:cNvPr id="57" name="Shape 55"/>
+          <p:cNvSpPr/>
+          <p:nvPr/>
+        </p:nvSpPr>
+        <p:spPr>
+          <a:xfrm>
+            <a:off x="8275320" y="4517136"/>
+            <a:ext cx="420624" cy="36576"/>
+          </a:xfrm>
+          <a:prstGeom prst="roundRect">
+            <a:avLst>
+              <a:gd name="adj" fmla="val 50000"/>
+            </a:avLst>
+          </a:prstGeom>
+          <a:solidFill>
+            <a:srgbClr val="FFFFFF">
+              <a:alpha val="22000"/>
+            </a:srgbClr>
+          </a:solidFill>
+          <a:ln w="12700">
+            <a:solidFill>
+              <a:srgbClr val="FFFFFF">
+                <a:alpha val="0"/>
+              </a:srgbClr>
+            </a:solidFill>
+            <a:prstDash val="solid"/>
+          </a:ln>
+        </p:spPr>
       </p:sp>
       <p:sp>
         <p:nvSpPr>
@@ -5624,75 +5588,63 @@
       </p:sp>
       <p:sp>
         <p:nvSpPr>
-          <p:cNvPr id="59" name="Text 57"/>
-          <p:cNvSpPr/>
-          <p:nvPr/>
-        </p:nvSpPr>
-        <p:spPr>
-          <a:xfrm>
-            <a:off x="9262872" y="4160520"/>
-            <a:ext cx="914400" cy="118872"/>
-          </a:xfrm>
-          <a:prstGeom prst="rect">
-            <a:avLst/>
-          </a:prstGeom>
-          <a:noFill/>
-          <a:ln/>
-        </p:spPr>
-        <p:txBody>
-          <a:bodyPr wrap="square" lIns="0" tIns="0" rIns="0" bIns="0" rtlCol="0" anchor="ctr"/>
-          <a:lstStyle/>
-          <a:p>
-            <a:pPr indent="0" marL="0">
-              <a:buNone/>
-            </a:pPr>
-            <a:r>
-              <a:rPr lang="en-US" sz="850" b="1" dirty="0">
-                <a:solidFill>
-                  <a:srgbClr val="F7F2EE"/>
-                </a:solidFill>
-              </a:rPr>
-              <a:t>Confirm</a:t>
-            </a:r>
-            <a:endParaRPr lang="en-US" sz="850" dirty="0"/>
-          </a:p>
-        </p:txBody>
-      </p:sp>
-      <p:sp>
-        <p:nvSpPr>
-          <p:cNvPr id="60" name="Text 58"/>
-          <p:cNvSpPr/>
-          <p:nvPr/>
-        </p:nvSpPr>
-        <p:spPr>
-          <a:xfrm>
-            <a:off x="9262872" y="4352544"/>
-            <a:ext cx="914400" cy="128016"/>
-          </a:xfrm>
-          <a:prstGeom prst="rect">
-            <a:avLst/>
-          </a:prstGeom>
-          <a:noFill/>
-          <a:ln/>
-        </p:spPr>
-        <p:txBody>
-          <a:bodyPr wrap="square" lIns="0" tIns="0" rIns="0" bIns="0" rtlCol="0" anchor="ctr"/>
-          <a:lstStyle/>
-          <a:p>
-            <a:pPr indent="0" marL="0">
-              <a:buNone/>
-            </a:pPr>
-            <a:r>
-              <a:rPr lang="en-US" sz="750" b="1" dirty="0">
-                <a:solidFill>
-                  <a:srgbClr val="B8B0AA"/>
-                </a:solidFill>
-              </a:rPr>
-              <a:t>User approves</a:t>
-            </a:r>
-            <a:endParaRPr lang="en-US" sz="750" dirty="0"/>
-          </a:p>
-        </p:txBody>
+          <p:cNvPr id="59" name="Shape 57"/>
+          <p:cNvSpPr/>
+          <p:nvPr/>
+        </p:nvSpPr>
+        <p:spPr>
+          <a:xfrm>
+            <a:off x="9573768" y="4187952"/>
+            <a:ext cx="292608" cy="292608"/>
+          </a:xfrm>
+          <a:prstGeom prst="ellipse">
+            <a:avLst/>
+          </a:prstGeom>
+          <a:solidFill>
+            <a:srgbClr val="8E59FF">
+              <a:alpha val="92000"/>
+            </a:srgbClr>
+          </a:solidFill>
+          <a:ln w="10160">
+            <a:solidFill>
+              <a:srgbClr val="FFFFFF">
+                <a:alpha val="20000"/>
+              </a:srgbClr>
+            </a:solidFill>
+            <a:prstDash val="solid"/>
+          </a:ln>
+        </p:spPr>
+      </p:sp>
+      <p:sp>
+        <p:nvSpPr>
+          <p:cNvPr id="60" name="Shape 58"/>
+          <p:cNvSpPr/>
+          <p:nvPr/>
+        </p:nvSpPr>
+        <p:spPr>
+          <a:xfrm>
+            <a:off x="9509760" y="4517136"/>
+            <a:ext cx="420624" cy="36576"/>
+          </a:xfrm>
+          <a:prstGeom prst="roundRect">
+            <a:avLst>
+              <a:gd name="adj" fmla="val 50000"/>
+            </a:avLst>
+          </a:prstGeom>
+          <a:solidFill>
+            <a:srgbClr val="FFFFFF">
+              <a:alpha val="22000"/>
+            </a:srgbClr>
+          </a:solidFill>
+          <a:ln w="12700">
+            <a:solidFill>
+              <a:srgbClr val="FFFFFF">
+                <a:alpha val="0"/>
+              </a:srgbClr>
+            </a:solidFill>
+            <a:prstDash val="solid"/>
+          </a:ln>
+        </p:spPr>
       </p:sp>
       <p:sp>
         <p:nvSpPr>

</xml_diff>